<commit_message>
fix: purge all StageScout references from business PPTX files
Replaced 15 instances across Business Plan (8) and Pitch Deck (7).
StageScout should never be used in this project again.
</commit_message>
<xml_diff>
--- a/data/docs/business/GigLift_Business_Plan.pptx
+++ b/data/docs/business/GigLift_Business_Plan.pptx
@@ -3212,7 +3212,7 @@
               </a:defRPr>
             </a:pPr>
             <a:r>
-              <a:t>STAGESCOUT</a:t>
+              <a:t>GIGLIFT</a:t>
             </a:r>
           </a:p>
         </p:txBody>
@@ -3392,7 +3392,7 @@
               </a:defRPr>
             </a:pPr>
             <a:r>
-              <a:t>stagescout-app.vercel.app</a:t>
+              <a:t>giglift-app.vercel.app</a:t>
             </a:r>
           </a:p>
         </p:txBody>
@@ -6596,7 +6596,7 @@
                         </a:defRPr>
                       </a:pPr>
                       <a:r>
-                        <a:t>StageScout</a:t>
+                        <a:t>GigLift</a:t>
                       </a:r>
                     </a:p>
                   </a:txBody>
@@ -12095,7 +12095,7 @@
               </a:defRPr>
             </a:pPr>
             <a:r>
-              <a:t>STAGESCOUT</a:t>
+              <a:t>GIGLIFT</a:t>
             </a:r>
           </a:p>
         </p:txBody>
@@ -12203,7 +12203,7 @@
               </a:defRPr>
             </a:pPr>
             <a:r>
-              <a:t>stagescout-app.vercel.app</a:t>
+              <a:t>giglift-app.vercel.app</a:t>
             </a:r>
           </a:p>
         </p:txBody>
@@ -12459,7 +12459,7 @@
               </a:defRPr>
             </a:pPr>
             <a:r>
-              <a:t>StageScout is an AI-powered lead discovery platform that helps musicians — DJs, bands, solo artists, and music teachers — find and book gigs automatically.</a:t>
+              <a:t>GigLift is an AI-powered lead discovery platform that helps musicians — DJs, bands, solo artists, and music teachers — find and book gigs automatically.</a:t>
             </a:r>
             <a:br/>
             <a:br/>
@@ -12469,7 +12469,7 @@
             <a:br/>
             <a:br/>
             <a:r>
-              <a:t>Unlike passive listing marketplaces where musicians compete for posted gigs, StageScout is a proactive outbound lead engine — it finds opportunities the artist didn't know existed.</a:t>
+              <a:t>Unlike passive listing marketplaces where musicians compete for posted gigs, GigLift is a proactive outbound lead engine — it finds opportunities the artist didn't know existed.</a:t>
             </a:r>
           </a:p>
         </p:txBody>
@@ -12585,7 +12585,7 @@
                         </a:defRPr>
                       </a:pPr>
                       <a:r>
-                        <a:t>Deployed at stagescout-app.vercel.app</a:t>
+                        <a:t>Deployed at giglift-app.vercel.app</a:t>
                       </a:r>
                     </a:p>
                   </a:txBody>

</xml_diff>